<commit_message>
subida graficos 1 dashboard
</commit_message>
<xml_diff>
--- a/dashboard/diseño_dashboard.pptx
+++ b/dashboard/diseño_dashboard.pptx
@@ -6,6 +6,7 @@
   </p:sldMasterIdLst>
   <p:sldIdLst>
     <p:sldId id="257" r:id="rId2"/>
+    <p:sldId id="258" r:id="rId3"/>
   </p:sldIdLst>
   <p:sldSz cx="12192000" cy="6858000"/>
   <p:notesSz cx="6858000" cy="9144000"/>
@@ -4056,6 +4057,642 @@
 </p:sld>
 </file>
 
+<file path=ppt/slides/slide2.xml><?xml version="1.0" encoding="utf-8"?>
+<p:sld xmlns:a="http://schemas.openxmlformats.org/drawingml/2006/main" xmlns:r="http://schemas.openxmlformats.org/officeDocument/2006/relationships" xmlns:p="http://schemas.openxmlformats.org/presentationml/2006/main">
+  <p:cSld>
+    <p:bg>
+      <p:bgPr>
+        <a:solidFill>
+          <a:srgbClr val="F5F7FA"/>
+        </a:solidFill>
+        <a:effectLst/>
+      </p:bgPr>
+    </p:bg>
+    <p:spTree>
+      <p:nvGrpSpPr>
+        <p:cNvPr id="1" name="">
+          <a:extLst>
+            <a:ext uri="{FF2B5EF4-FFF2-40B4-BE49-F238E27FC236}">
+              <a16:creationId xmlns:a16="http://schemas.microsoft.com/office/drawing/2014/main" id="{7B022167-42C3-1425-9095-1EC3ED9BEE40}"/>
+            </a:ext>
+          </a:extLst>
+        </p:cNvPr>
+        <p:cNvGrpSpPr/>
+        <p:nvPr/>
+      </p:nvGrpSpPr>
+      <p:grpSpPr>
+        <a:xfrm>
+          <a:off x="0" y="0"/>
+          <a:ext cx="0" cy="0"/>
+          <a:chOff x="0" y="0"/>
+          <a:chExt cx="0" cy="0"/>
+        </a:xfrm>
+      </p:grpSpPr>
+      <p:sp>
+        <p:nvSpPr>
+          <p:cNvPr id="4" name="Rectángulo: esquinas redondeadas 3">
+            <a:extLst>
+              <a:ext uri="{FF2B5EF4-FFF2-40B4-BE49-F238E27FC236}">
+                <a16:creationId xmlns:a16="http://schemas.microsoft.com/office/drawing/2014/main" id="{8637645C-D5B7-EB5C-CAAF-0E3D133D8A28}"/>
+              </a:ext>
+            </a:extLst>
+          </p:cNvPr>
+          <p:cNvSpPr/>
+          <p:nvPr/>
+        </p:nvSpPr>
+        <p:spPr>
+          <a:xfrm>
+            <a:off x="141514" y="152400"/>
+            <a:ext cx="11919857" cy="990600"/>
+          </a:xfrm>
+          <a:prstGeom prst="roundRect">
+            <a:avLst/>
+          </a:prstGeom>
+          <a:solidFill>
+            <a:srgbClr val="536B78"/>
+          </a:solidFill>
+          <a:ln w="28575">
+            <a:noFill/>
+          </a:ln>
+        </p:spPr>
+        <p:style>
+          <a:lnRef idx="2">
+            <a:schemeClr val="accent1">
+              <a:shade val="15000"/>
+            </a:schemeClr>
+          </a:lnRef>
+          <a:fillRef idx="1">
+            <a:schemeClr val="accent1"/>
+          </a:fillRef>
+          <a:effectRef idx="0">
+            <a:schemeClr val="accent1"/>
+          </a:effectRef>
+          <a:fontRef idx="minor">
+            <a:schemeClr val="lt1"/>
+          </a:fontRef>
+        </p:style>
+        <p:txBody>
+          <a:bodyPr rtlCol="0" anchor="ctr"/>
+          <a:lstStyle/>
+          <a:p>
+            <a:pPr algn="ctr"/>
+            <a:endParaRPr lang="es-ES"/>
+          </a:p>
+        </p:txBody>
+      </p:sp>
+      <p:sp>
+        <p:nvSpPr>
+          <p:cNvPr id="5" name="Rectángulo: esquinas redondeadas 4">
+            <a:extLst>
+              <a:ext uri="{FF2B5EF4-FFF2-40B4-BE49-F238E27FC236}">
+                <a16:creationId xmlns:a16="http://schemas.microsoft.com/office/drawing/2014/main" id="{7208E69A-BD30-D958-098F-AAB2F05ED209}"/>
+              </a:ext>
+            </a:extLst>
+          </p:cNvPr>
+          <p:cNvSpPr/>
+          <p:nvPr/>
+        </p:nvSpPr>
+        <p:spPr>
+          <a:xfrm>
+            <a:off x="199188" y="1259806"/>
+            <a:ext cx="2754324" cy="729343"/>
+          </a:xfrm>
+          <a:prstGeom prst="roundRect">
+            <a:avLst/>
+          </a:prstGeom>
+          <a:solidFill>
+            <a:srgbClr val="FFFFFF"/>
+          </a:solidFill>
+          <a:ln w="12700">
+            <a:solidFill>
+              <a:srgbClr val="DCE3EA"/>
+            </a:solidFill>
+          </a:ln>
+        </p:spPr>
+        <p:style>
+          <a:lnRef idx="2">
+            <a:schemeClr val="accent1">
+              <a:shade val="15000"/>
+            </a:schemeClr>
+          </a:lnRef>
+          <a:fillRef idx="1">
+            <a:schemeClr val="accent1"/>
+          </a:fillRef>
+          <a:effectRef idx="0">
+            <a:schemeClr val="accent1"/>
+          </a:effectRef>
+          <a:fontRef idx="minor">
+            <a:schemeClr val="lt1"/>
+          </a:fontRef>
+        </p:style>
+        <p:txBody>
+          <a:bodyPr rtlCol="0" anchor="ctr"/>
+          <a:lstStyle/>
+          <a:p>
+            <a:pPr algn="ctr"/>
+            <a:endParaRPr lang="es-ES"/>
+          </a:p>
+        </p:txBody>
+      </p:sp>
+      <p:sp>
+        <p:nvSpPr>
+          <p:cNvPr id="14" name="Rectángulo: esquinas redondeadas 13">
+            <a:extLst>
+              <a:ext uri="{FF2B5EF4-FFF2-40B4-BE49-F238E27FC236}">
+                <a16:creationId xmlns:a16="http://schemas.microsoft.com/office/drawing/2014/main" id="{EA9A381F-BC18-AD95-5666-B21DDD76BF47}"/>
+              </a:ext>
+            </a:extLst>
+          </p:cNvPr>
+          <p:cNvSpPr/>
+          <p:nvPr/>
+        </p:nvSpPr>
+        <p:spPr>
+          <a:xfrm>
+            <a:off x="141514" y="2161216"/>
+            <a:ext cx="2885150" cy="2547944"/>
+          </a:xfrm>
+          <a:prstGeom prst="roundRect">
+            <a:avLst/>
+          </a:prstGeom>
+          <a:solidFill>
+            <a:srgbClr val="FFFFFF"/>
+          </a:solidFill>
+          <a:ln w="12700">
+            <a:solidFill>
+              <a:srgbClr val="DCE3EA"/>
+            </a:solidFill>
+          </a:ln>
+        </p:spPr>
+        <p:style>
+          <a:lnRef idx="2">
+            <a:schemeClr val="accent1">
+              <a:shade val="15000"/>
+            </a:schemeClr>
+          </a:lnRef>
+          <a:fillRef idx="1">
+            <a:schemeClr val="accent1"/>
+          </a:fillRef>
+          <a:effectRef idx="0">
+            <a:schemeClr val="accent1"/>
+          </a:effectRef>
+          <a:fontRef idx="minor">
+            <a:schemeClr val="lt1"/>
+          </a:fontRef>
+        </p:style>
+        <p:txBody>
+          <a:bodyPr rtlCol="0" anchor="ctr"/>
+          <a:lstStyle/>
+          <a:p>
+            <a:pPr algn="ctr"/>
+            <a:endParaRPr lang="es-ES"/>
+          </a:p>
+        </p:txBody>
+      </p:sp>
+      <p:sp>
+        <p:nvSpPr>
+          <p:cNvPr id="11" name="Rectángulo: esquinas redondeadas 10">
+            <a:extLst>
+              <a:ext uri="{FF2B5EF4-FFF2-40B4-BE49-F238E27FC236}">
+                <a16:creationId xmlns:a16="http://schemas.microsoft.com/office/drawing/2014/main" id="{95F66944-BA2D-5D7F-0C9C-52B1016CFD39}"/>
+              </a:ext>
+            </a:extLst>
+          </p:cNvPr>
+          <p:cNvSpPr/>
+          <p:nvPr/>
+        </p:nvSpPr>
+        <p:spPr>
+          <a:xfrm>
+            <a:off x="3222804" y="1259805"/>
+            <a:ext cx="2754324" cy="729343"/>
+          </a:xfrm>
+          <a:prstGeom prst="roundRect">
+            <a:avLst/>
+          </a:prstGeom>
+          <a:solidFill>
+            <a:srgbClr val="FFFFFF"/>
+          </a:solidFill>
+          <a:ln w="12700">
+            <a:solidFill>
+              <a:srgbClr val="DCE3EA"/>
+            </a:solidFill>
+          </a:ln>
+        </p:spPr>
+        <p:style>
+          <a:lnRef idx="2">
+            <a:schemeClr val="accent1">
+              <a:shade val="15000"/>
+            </a:schemeClr>
+          </a:lnRef>
+          <a:fillRef idx="1">
+            <a:schemeClr val="accent1"/>
+          </a:fillRef>
+          <a:effectRef idx="0">
+            <a:schemeClr val="accent1"/>
+          </a:effectRef>
+          <a:fontRef idx="minor">
+            <a:schemeClr val="lt1"/>
+          </a:fontRef>
+        </p:style>
+        <p:txBody>
+          <a:bodyPr rtlCol="0" anchor="ctr"/>
+          <a:lstStyle/>
+          <a:p>
+            <a:pPr algn="ctr"/>
+            <a:endParaRPr lang="es-ES"/>
+          </a:p>
+        </p:txBody>
+      </p:sp>
+      <p:sp>
+        <p:nvSpPr>
+          <p:cNvPr id="15" name="Rectángulo: esquinas redondeadas 14">
+            <a:extLst>
+              <a:ext uri="{FF2B5EF4-FFF2-40B4-BE49-F238E27FC236}">
+                <a16:creationId xmlns:a16="http://schemas.microsoft.com/office/drawing/2014/main" id="{AAA3F16F-3D53-B404-913A-ACACC64E2483}"/>
+              </a:ext>
+            </a:extLst>
+          </p:cNvPr>
+          <p:cNvSpPr/>
+          <p:nvPr/>
+        </p:nvSpPr>
+        <p:spPr>
+          <a:xfrm>
+            <a:off x="6246420" y="1259804"/>
+            <a:ext cx="2754324" cy="729343"/>
+          </a:xfrm>
+          <a:prstGeom prst="roundRect">
+            <a:avLst/>
+          </a:prstGeom>
+          <a:solidFill>
+            <a:srgbClr val="FFFFFF"/>
+          </a:solidFill>
+          <a:ln w="12700">
+            <a:solidFill>
+              <a:srgbClr val="DCE3EA"/>
+            </a:solidFill>
+          </a:ln>
+        </p:spPr>
+        <p:style>
+          <a:lnRef idx="2">
+            <a:schemeClr val="accent1">
+              <a:shade val="15000"/>
+            </a:schemeClr>
+          </a:lnRef>
+          <a:fillRef idx="1">
+            <a:schemeClr val="accent1"/>
+          </a:fillRef>
+          <a:effectRef idx="0">
+            <a:schemeClr val="accent1"/>
+          </a:effectRef>
+          <a:fontRef idx="minor">
+            <a:schemeClr val="lt1"/>
+          </a:fontRef>
+        </p:style>
+        <p:txBody>
+          <a:bodyPr rtlCol="0" anchor="ctr"/>
+          <a:lstStyle/>
+          <a:p>
+            <a:pPr algn="ctr"/>
+            <a:endParaRPr lang="es-ES"/>
+          </a:p>
+        </p:txBody>
+      </p:sp>
+      <p:sp>
+        <p:nvSpPr>
+          <p:cNvPr id="19" name="Rectángulo: esquinas redondeadas 18">
+            <a:extLst>
+              <a:ext uri="{FF2B5EF4-FFF2-40B4-BE49-F238E27FC236}">
+                <a16:creationId xmlns:a16="http://schemas.microsoft.com/office/drawing/2014/main" id="{DF6E0766-DD72-911A-2BD7-BDDBF509C8D9}"/>
+              </a:ext>
+            </a:extLst>
+          </p:cNvPr>
+          <p:cNvSpPr/>
+          <p:nvPr/>
+        </p:nvSpPr>
+        <p:spPr>
+          <a:xfrm>
+            <a:off x="9238488" y="1259804"/>
+            <a:ext cx="2754324" cy="729343"/>
+          </a:xfrm>
+          <a:prstGeom prst="roundRect">
+            <a:avLst/>
+          </a:prstGeom>
+          <a:solidFill>
+            <a:srgbClr val="FFFFFF"/>
+          </a:solidFill>
+          <a:ln w="12700">
+            <a:solidFill>
+              <a:srgbClr val="DCE3EA"/>
+            </a:solidFill>
+          </a:ln>
+        </p:spPr>
+        <p:style>
+          <a:lnRef idx="2">
+            <a:schemeClr val="accent1">
+              <a:shade val="15000"/>
+            </a:schemeClr>
+          </a:lnRef>
+          <a:fillRef idx="1">
+            <a:schemeClr val="accent1"/>
+          </a:fillRef>
+          <a:effectRef idx="0">
+            <a:schemeClr val="accent1"/>
+          </a:effectRef>
+          <a:fontRef idx="minor">
+            <a:schemeClr val="lt1"/>
+          </a:fontRef>
+        </p:style>
+        <p:txBody>
+          <a:bodyPr rtlCol="0" anchor="ctr"/>
+          <a:lstStyle/>
+          <a:p>
+            <a:pPr algn="ctr"/>
+            <a:endParaRPr lang="es-ES"/>
+          </a:p>
+        </p:txBody>
+      </p:sp>
+      <p:sp>
+        <p:nvSpPr>
+          <p:cNvPr id="34" name="Rectángulo: esquinas redondeadas 33">
+            <a:extLst>
+              <a:ext uri="{FF2B5EF4-FFF2-40B4-BE49-F238E27FC236}">
+                <a16:creationId xmlns:a16="http://schemas.microsoft.com/office/drawing/2014/main" id="{F98EE72C-639D-9034-0B27-B0D13CF69E6C}"/>
+              </a:ext>
+            </a:extLst>
+          </p:cNvPr>
+          <p:cNvSpPr/>
+          <p:nvPr/>
+        </p:nvSpPr>
+        <p:spPr>
+          <a:xfrm>
+            <a:off x="3149356" y="2161216"/>
+            <a:ext cx="2885150" cy="2547944"/>
+          </a:xfrm>
+          <a:prstGeom prst="roundRect">
+            <a:avLst/>
+          </a:prstGeom>
+          <a:solidFill>
+            <a:srgbClr val="FFFFFF"/>
+          </a:solidFill>
+          <a:ln w="12700">
+            <a:solidFill>
+              <a:srgbClr val="DCE3EA"/>
+            </a:solidFill>
+          </a:ln>
+        </p:spPr>
+        <p:style>
+          <a:lnRef idx="2">
+            <a:schemeClr val="accent1">
+              <a:shade val="15000"/>
+            </a:schemeClr>
+          </a:lnRef>
+          <a:fillRef idx="1">
+            <a:schemeClr val="accent1"/>
+          </a:fillRef>
+          <a:effectRef idx="0">
+            <a:schemeClr val="accent1"/>
+          </a:effectRef>
+          <a:fontRef idx="minor">
+            <a:schemeClr val="lt1"/>
+          </a:fontRef>
+        </p:style>
+        <p:txBody>
+          <a:bodyPr rtlCol="0" anchor="ctr"/>
+          <a:lstStyle/>
+          <a:p>
+            <a:pPr algn="ctr"/>
+            <a:endParaRPr lang="es-ES"/>
+          </a:p>
+        </p:txBody>
+      </p:sp>
+      <p:sp>
+        <p:nvSpPr>
+          <p:cNvPr id="36" name="Rectángulo: esquinas redondeadas 35">
+            <a:extLst>
+              <a:ext uri="{FF2B5EF4-FFF2-40B4-BE49-F238E27FC236}">
+                <a16:creationId xmlns:a16="http://schemas.microsoft.com/office/drawing/2014/main" id="{C5A8C3B8-4F55-6B1E-63B8-6B42DDD6D721}"/>
+              </a:ext>
+            </a:extLst>
+          </p:cNvPr>
+          <p:cNvSpPr/>
+          <p:nvPr/>
+        </p:nvSpPr>
+        <p:spPr>
+          <a:xfrm>
+            <a:off x="6157198" y="2161216"/>
+            <a:ext cx="2885150" cy="2547944"/>
+          </a:xfrm>
+          <a:prstGeom prst="roundRect">
+            <a:avLst/>
+          </a:prstGeom>
+          <a:solidFill>
+            <a:srgbClr val="FFFFFF"/>
+          </a:solidFill>
+          <a:ln w="12700">
+            <a:solidFill>
+              <a:srgbClr val="DCE3EA"/>
+            </a:solidFill>
+          </a:ln>
+        </p:spPr>
+        <p:style>
+          <a:lnRef idx="2">
+            <a:schemeClr val="accent1">
+              <a:shade val="15000"/>
+            </a:schemeClr>
+          </a:lnRef>
+          <a:fillRef idx="1">
+            <a:schemeClr val="accent1"/>
+          </a:fillRef>
+          <a:effectRef idx="0">
+            <a:schemeClr val="accent1"/>
+          </a:effectRef>
+          <a:fontRef idx="minor">
+            <a:schemeClr val="lt1"/>
+          </a:fontRef>
+        </p:style>
+        <p:txBody>
+          <a:bodyPr rtlCol="0" anchor="ctr"/>
+          <a:lstStyle/>
+          <a:p>
+            <a:pPr algn="ctr"/>
+            <a:endParaRPr lang="es-ES"/>
+          </a:p>
+        </p:txBody>
+      </p:sp>
+      <p:sp>
+        <p:nvSpPr>
+          <p:cNvPr id="38" name="Rectángulo: esquinas redondeadas 37">
+            <a:extLst>
+              <a:ext uri="{FF2B5EF4-FFF2-40B4-BE49-F238E27FC236}">
+                <a16:creationId xmlns:a16="http://schemas.microsoft.com/office/drawing/2014/main" id="{185BCDDB-0BBD-2AF6-616E-56B7E9435251}"/>
+              </a:ext>
+            </a:extLst>
+          </p:cNvPr>
+          <p:cNvSpPr/>
+          <p:nvPr/>
+        </p:nvSpPr>
+        <p:spPr>
+          <a:xfrm>
+            <a:off x="9165040" y="2161216"/>
+            <a:ext cx="2827772" cy="2547944"/>
+          </a:xfrm>
+          <a:prstGeom prst="roundRect">
+            <a:avLst/>
+          </a:prstGeom>
+          <a:solidFill>
+            <a:srgbClr val="FFFFFF"/>
+          </a:solidFill>
+          <a:ln w="12700">
+            <a:solidFill>
+              <a:srgbClr val="DCE3EA"/>
+            </a:solidFill>
+          </a:ln>
+        </p:spPr>
+        <p:style>
+          <a:lnRef idx="2">
+            <a:schemeClr val="accent1">
+              <a:shade val="15000"/>
+            </a:schemeClr>
+          </a:lnRef>
+          <a:fillRef idx="1">
+            <a:schemeClr val="accent1"/>
+          </a:fillRef>
+          <a:effectRef idx="0">
+            <a:schemeClr val="accent1"/>
+          </a:effectRef>
+          <a:fontRef idx="minor">
+            <a:schemeClr val="lt1"/>
+          </a:fontRef>
+        </p:style>
+        <p:txBody>
+          <a:bodyPr rtlCol="0" anchor="ctr"/>
+          <a:lstStyle/>
+          <a:p>
+            <a:pPr algn="ctr"/>
+            <a:endParaRPr lang="es-ES"/>
+          </a:p>
+        </p:txBody>
+      </p:sp>
+      <p:sp>
+        <p:nvSpPr>
+          <p:cNvPr id="40" name="Rectángulo: esquinas redondeadas 39">
+            <a:extLst>
+              <a:ext uri="{FF2B5EF4-FFF2-40B4-BE49-F238E27FC236}">
+                <a16:creationId xmlns:a16="http://schemas.microsoft.com/office/drawing/2014/main" id="{0C819DAB-48D7-A812-6903-19F2DCBEF5AF}"/>
+              </a:ext>
+            </a:extLst>
+          </p:cNvPr>
+          <p:cNvSpPr/>
+          <p:nvPr/>
+        </p:nvSpPr>
+        <p:spPr>
+          <a:xfrm>
+            <a:off x="199188" y="4868852"/>
+            <a:ext cx="5835318" cy="1836748"/>
+          </a:xfrm>
+          <a:prstGeom prst="roundRect">
+            <a:avLst/>
+          </a:prstGeom>
+          <a:solidFill>
+            <a:srgbClr val="FFFFFF"/>
+          </a:solidFill>
+          <a:ln w="12700">
+            <a:solidFill>
+              <a:srgbClr val="DCE3EA"/>
+            </a:solidFill>
+          </a:ln>
+        </p:spPr>
+        <p:style>
+          <a:lnRef idx="2">
+            <a:schemeClr val="accent1">
+              <a:shade val="15000"/>
+            </a:schemeClr>
+          </a:lnRef>
+          <a:fillRef idx="1">
+            <a:schemeClr val="accent1"/>
+          </a:fillRef>
+          <a:effectRef idx="0">
+            <a:schemeClr val="accent1"/>
+          </a:effectRef>
+          <a:fontRef idx="minor">
+            <a:schemeClr val="lt1"/>
+          </a:fontRef>
+        </p:style>
+        <p:txBody>
+          <a:bodyPr rtlCol="0" anchor="ctr"/>
+          <a:lstStyle/>
+          <a:p>
+            <a:pPr algn="ctr"/>
+            <a:endParaRPr lang="es-ES"/>
+          </a:p>
+        </p:txBody>
+      </p:sp>
+      <p:sp>
+        <p:nvSpPr>
+          <p:cNvPr id="42" name="Rectángulo: esquinas redondeadas 41">
+            <a:extLst>
+              <a:ext uri="{FF2B5EF4-FFF2-40B4-BE49-F238E27FC236}">
+                <a16:creationId xmlns:a16="http://schemas.microsoft.com/office/drawing/2014/main" id="{71C6B64B-A0CD-27A8-5AC5-97BDE1B9138D}"/>
+              </a:ext>
+            </a:extLst>
+          </p:cNvPr>
+          <p:cNvSpPr/>
+          <p:nvPr/>
+        </p:nvSpPr>
+        <p:spPr>
+          <a:xfrm>
+            <a:off x="6157198" y="4868852"/>
+            <a:ext cx="5835616" cy="1836748"/>
+          </a:xfrm>
+          <a:prstGeom prst="roundRect">
+            <a:avLst/>
+          </a:prstGeom>
+          <a:solidFill>
+            <a:srgbClr val="FFFFFF"/>
+          </a:solidFill>
+          <a:ln w="12700">
+            <a:solidFill>
+              <a:srgbClr val="DCE3EA"/>
+            </a:solidFill>
+          </a:ln>
+        </p:spPr>
+        <p:style>
+          <a:lnRef idx="2">
+            <a:schemeClr val="accent1">
+              <a:shade val="15000"/>
+            </a:schemeClr>
+          </a:lnRef>
+          <a:fillRef idx="1">
+            <a:schemeClr val="accent1"/>
+          </a:fillRef>
+          <a:effectRef idx="0">
+            <a:schemeClr val="accent1"/>
+          </a:effectRef>
+          <a:fontRef idx="minor">
+            <a:schemeClr val="lt1"/>
+          </a:fontRef>
+        </p:style>
+        <p:txBody>
+          <a:bodyPr rtlCol="0" anchor="ctr"/>
+          <a:lstStyle/>
+          <a:p>
+            <a:pPr algn="ctr"/>
+            <a:endParaRPr lang="es-ES"/>
+          </a:p>
+        </p:txBody>
+      </p:sp>
+    </p:spTree>
+    <p:extLst>
+      <p:ext uri="{BB962C8B-B14F-4D97-AF65-F5344CB8AC3E}">
+        <p14:creationId xmlns:p14="http://schemas.microsoft.com/office/powerpoint/2010/main" val="3415757470"/>
+      </p:ext>
+    </p:extLst>
+  </p:cSld>
+  <p:clrMapOvr>
+    <a:masterClrMapping/>
+  </p:clrMapOvr>
+</p:sld>
+</file>
+
 <file path=ppt/theme/theme1.xml><?xml version="1.0" encoding="utf-8"?>
 <a:theme xmlns:a="http://schemas.openxmlformats.org/drawingml/2006/main" name="Tema de Office">
   <a:themeElements>

</xml_diff>